<commit_message>
Bump version; restore logo transparency
Bump package version to 1.6.1 and add NEWS entry. Revert flattening of the Grattan logo so it remains transparent (so the grey header shows through) and adjust the blog title wrap width to avoid overlap with the logo. Update data-raw script (create sysdata.R) and regenerate binary sysdata/chart_types_ext RDA files and the blog PPTX template. Minor edits to ai_guide_template.md: guidance on newlines/paste and add grattan_x_continuous(expand_right = 0.1) plus theme_grattan() in the example.
</commit_message>
<xml_diff>
--- a/inst/extdata/template_blog.pptx
+++ b/inst/extdata/template_blog.pptx
@@ -203,7 +203,7 @@
           <a:p>
             <a:fld id="{E6375376-077A-8F42-9E71-155E70FB596E}" type="datetimeFigureOut">
               <a:rPr lang="en-US" smtClean="0"/>
-              <a:t>4/17/26</a:t>
+              <a:t>7/14/26</a:t>
             </a:fld>
             <a:endParaRPr lang="en-US"/>
           </a:p>
@@ -1153,7 +1153,7 @@
           <a:p>
             <a:fld id="{184C34C6-D93D-964F-98F1-8B05274CB5BF}" type="datetimeFigureOut">
               <a:rPr lang="en-US" smtClean="0"/>
-              <a:t>4/17/26</a:t>
+              <a:t>7/14/26</a:t>
             </a:fld>
             <a:endParaRPr lang="en-US"/>
           </a:p>
@@ -1374,7 +1374,7 @@
           <a:p>
             <a:fld id="{184C34C6-D93D-964F-98F1-8B05274CB5BF}" type="datetimeFigureOut">
               <a:rPr lang="en-US" smtClean="0"/>
-              <a:t>4/17/26</a:t>
+              <a:t>7/14/26</a:t>
             </a:fld>
             <a:endParaRPr lang="en-US" dirty="0"/>
           </a:p>
@@ -1698,7 +1698,7 @@
           <a:p>
             <a:fld id="{184C34C6-D93D-964F-98F1-8B05274CB5BF}" type="datetimeFigureOut">
               <a:rPr lang="en-US" smtClean="0"/>
-              <a:t>4/17/26</a:t>
+              <a:t>7/14/26</a:t>
             </a:fld>
             <a:endParaRPr lang="en-US" dirty="0"/>
           </a:p>
@@ -2215,7 +2215,7 @@
           <a:p>
             <a:fld id="{184C34C6-D93D-964F-98F1-8B05274CB5BF}" type="datetimeFigureOut">
               <a:rPr lang="en-US" smtClean="0"/>
-              <a:t>4/17/26</a:t>
+              <a:t>7/14/26</a:t>
             </a:fld>
             <a:endParaRPr lang="en-US" dirty="0"/>
           </a:p>
@@ -2485,7 +2485,7 @@
         <p:spPr>
           <a:xfrm>
             <a:off x="196919" y="319665"/>
-            <a:ext cx="6079488" cy="656677"/>
+            <a:ext cx="6254138" cy="656677"/>
           </a:xfrm>
           <a:prstGeom prst="rect">
             <a:avLst/>
@@ -2879,7 +2879,7 @@
           <a:p>
             <a:fld id="{184C34C6-D93D-964F-98F1-8B05274CB5BF}" type="datetimeFigureOut">
               <a:rPr lang="en-AU" noProof="0" smtClean="0"/>
-              <a:t>17/4/2026</a:t>
+              <a:t>14/7/2026</a:t>
             </a:fld>
             <a:endParaRPr lang="en-AU" noProof="0"/>
           </a:p>

</xml_diff>

<commit_message>
Bump version to 1.6.2; restore logo transparency
Bump package version to 1.6.2 and add NEWS entry. Revert flattening of the
Grattan logo so it remains transparent (so the grey header shows through)
and reduce the blog title wrap width to avoid overlap with the logo. Update
data-raw script (create sysdata.R) and regenerate binary sysdata /
chart_types_ext RDA files and the blog PPTX template. Minor doc edits to
ai_guide_template.md.

Co-Authored-By: Claude Opus 4.8 <noreply@anthropic.com>
</commit_message>
<xml_diff>
--- a/inst/extdata/template_blog.pptx
+++ b/inst/extdata/template_blog.pptx
@@ -203,7 +203,7 @@
           <a:p>
             <a:fld id="{E6375376-077A-8F42-9E71-155E70FB596E}" type="datetimeFigureOut">
               <a:rPr lang="en-US" smtClean="0"/>
-              <a:t>4/17/26</a:t>
+              <a:t>7/14/26</a:t>
             </a:fld>
             <a:endParaRPr lang="en-US"/>
           </a:p>
@@ -1153,7 +1153,7 @@
           <a:p>
             <a:fld id="{184C34C6-D93D-964F-98F1-8B05274CB5BF}" type="datetimeFigureOut">
               <a:rPr lang="en-US" smtClean="0"/>
-              <a:t>4/17/26</a:t>
+              <a:t>7/14/26</a:t>
             </a:fld>
             <a:endParaRPr lang="en-US"/>
           </a:p>
@@ -1374,7 +1374,7 @@
           <a:p>
             <a:fld id="{184C34C6-D93D-964F-98F1-8B05274CB5BF}" type="datetimeFigureOut">
               <a:rPr lang="en-US" smtClean="0"/>
-              <a:t>4/17/26</a:t>
+              <a:t>7/14/26</a:t>
             </a:fld>
             <a:endParaRPr lang="en-US" dirty="0"/>
           </a:p>
@@ -1698,7 +1698,7 @@
           <a:p>
             <a:fld id="{184C34C6-D93D-964F-98F1-8B05274CB5BF}" type="datetimeFigureOut">
               <a:rPr lang="en-US" smtClean="0"/>
-              <a:t>4/17/26</a:t>
+              <a:t>7/14/26</a:t>
             </a:fld>
             <a:endParaRPr lang="en-US" dirty="0"/>
           </a:p>
@@ -2215,7 +2215,7 @@
           <a:p>
             <a:fld id="{184C34C6-D93D-964F-98F1-8B05274CB5BF}" type="datetimeFigureOut">
               <a:rPr lang="en-US" smtClean="0"/>
-              <a:t>4/17/26</a:t>
+              <a:t>7/14/26</a:t>
             </a:fld>
             <a:endParaRPr lang="en-US" dirty="0"/>
           </a:p>
@@ -2485,7 +2485,7 @@
         <p:spPr>
           <a:xfrm>
             <a:off x="196919" y="319665"/>
-            <a:ext cx="6079488" cy="656677"/>
+            <a:ext cx="6254138" cy="656677"/>
           </a:xfrm>
           <a:prstGeom prst="rect">
             <a:avLst/>
@@ -2879,7 +2879,7 @@
           <a:p>
             <a:fld id="{184C34C6-D93D-964F-98F1-8B05274CB5BF}" type="datetimeFigureOut">
               <a:rPr lang="en-AU" noProof="0" smtClean="0"/>
-              <a:t>17/4/2026</a:t>
+              <a:t>14/7/2026</a:t>
             </a:fld>
             <a:endParaRPr lang="en-AU" noProof="0"/>
           </a:p>

</xml_diff>